<commit_message>
docs: actualiza mockups, presentacion y apuntes al nuevo estilo
</commit_message>
<xml_diff>
--- a/docs/PanolApp_Presentacion.pptx
+++ b/docs/PanolApp_Presentacion.pptx
@@ -1747,7 +1747,7 @@
     <p:bg>
       <p:bgPr>
         <a:solidFill>
-          <a:srgbClr val="2E6B4F"/>
+          <a:srgbClr val="1B2A41"/>
         </a:solidFill>
       </p:bgPr>
     </p:bg>
@@ -1864,7 +1864,7 @@
             <a:r>
               <a:rPr lang="en-US" sz="2400" dirty="0">
                 <a:solidFill>
-                  <a:srgbClr val="DDEBDD"/>
+                  <a:srgbClr val="F4A300"/>
                 </a:solidFill>
               </a:rPr>
               <a:t>Control de equipos y préstamos del pañol</a:t>
@@ -1998,14 +1998,34 @@
             <a:avLst/>
           </a:prstGeom>
           <a:solidFill>
-            <a:srgbClr val="2E6B4F"/>
+            <a:srgbClr val="1B2A41"/>
           </a:solidFill>
           <a:ln/>
         </p:spPr>
       </p:sp>
       <p:sp>
         <p:nvSpPr>
-          <p:cNvPr id="3" name="Text 1"/>
+          <p:cNvPr id="3" name="Shape 1"/>
+          <p:cNvSpPr/>
+          <p:nvPr/>
+        </p:nvSpPr>
+        <p:spPr>
+          <a:xfrm>
+            <a:off x="0" y="822960"/>
+            <a:ext cx="9144000" cy="45720"/>
+          </a:xfrm>
+          <a:prstGeom prst="rect">
+            <a:avLst/>
+          </a:prstGeom>
+          <a:solidFill>
+            <a:srgbClr val="F4A300"/>
+          </a:solidFill>
+          <a:ln/>
+        </p:spPr>
+      </p:sp>
+      <p:sp>
+        <p:nvSpPr>
+          <p:cNvPr id="4" name="Text 2"/>
           <p:cNvSpPr/>
           <p:nvPr/>
         </p:nvSpPr>
@@ -2044,7 +2064,7 @@
       </p:sp>
       <p:sp>
         <p:nvSpPr>
-          <p:cNvPr id="4" name="Text 2"/>
+          <p:cNvPr id="5" name="Text 3"/>
           <p:cNvSpPr/>
           <p:nvPr/>
         </p:nvSpPr>
@@ -2080,7 +2100,7 @@
       </p:sp>
       <p:sp>
         <p:nvSpPr>
-          <p:cNvPr id="5" name="Text 3"/>
+          <p:cNvPr id="6" name="Text 4"/>
           <p:cNvSpPr/>
           <p:nvPr/>
         </p:nvSpPr>
@@ -2273,14 +2293,34 @@
             <a:avLst/>
           </a:prstGeom>
           <a:solidFill>
-            <a:srgbClr val="2E6B4F"/>
+            <a:srgbClr val="1B2A41"/>
           </a:solidFill>
           <a:ln/>
         </p:spPr>
       </p:sp>
       <p:sp>
         <p:nvSpPr>
-          <p:cNvPr id="3" name="Text 1"/>
+          <p:cNvPr id="3" name="Shape 1"/>
+          <p:cNvSpPr/>
+          <p:nvPr/>
+        </p:nvSpPr>
+        <p:spPr>
+          <a:xfrm>
+            <a:off x="0" y="822960"/>
+            <a:ext cx="9144000" cy="45720"/>
+          </a:xfrm>
+          <a:prstGeom prst="rect">
+            <a:avLst/>
+          </a:prstGeom>
+          <a:solidFill>
+            <a:srgbClr val="F4A300"/>
+          </a:solidFill>
+          <a:ln/>
+        </p:spPr>
+      </p:sp>
+      <p:sp>
+        <p:nvSpPr>
+          <p:cNvPr id="4" name="Text 2"/>
           <p:cNvSpPr/>
           <p:nvPr/>
         </p:nvSpPr>
@@ -2319,7 +2359,7 @@
       </p:sp>
       <p:sp>
         <p:nvSpPr>
-          <p:cNvPr id="4" name="Text 2"/>
+          <p:cNvPr id="5" name="Text 3"/>
           <p:cNvSpPr/>
           <p:nvPr/>
         </p:nvSpPr>
@@ -2355,7 +2395,7 @@
       </p:sp>
       <p:sp>
         <p:nvSpPr>
-          <p:cNvPr id="5" name="Text 3"/>
+          <p:cNvPr id="6" name="Text 4"/>
           <p:cNvSpPr/>
           <p:nvPr/>
         </p:nvSpPr>
@@ -2506,14 +2546,34 @@
             <a:avLst/>
           </a:prstGeom>
           <a:solidFill>
-            <a:srgbClr val="2E6B4F"/>
+            <a:srgbClr val="1B2A41"/>
           </a:solidFill>
           <a:ln/>
         </p:spPr>
       </p:sp>
       <p:sp>
         <p:nvSpPr>
-          <p:cNvPr id="3" name="Text 1"/>
+          <p:cNvPr id="3" name="Shape 1"/>
+          <p:cNvSpPr/>
+          <p:nvPr/>
+        </p:nvSpPr>
+        <p:spPr>
+          <a:xfrm>
+            <a:off x="0" y="822960"/>
+            <a:ext cx="9144000" cy="45720"/>
+          </a:xfrm>
+          <a:prstGeom prst="rect">
+            <a:avLst/>
+          </a:prstGeom>
+          <a:solidFill>
+            <a:srgbClr val="F4A300"/>
+          </a:solidFill>
+          <a:ln/>
+        </p:spPr>
+      </p:sp>
+      <p:sp>
+        <p:nvSpPr>
+          <p:cNvPr id="4" name="Text 2"/>
           <p:cNvSpPr/>
           <p:nvPr/>
         </p:nvSpPr>
@@ -2552,7 +2612,7 @@
       </p:sp>
       <p:sp>
         <p:nvSpPr>
-          <p:cNvPr id="4" name="Text 2"/>
+          <p:cNvPr id="5" name="Text 3"/>
           <p:cNvSpPr/>
           <p:nvPr/>
         </p:nvSpPr>
@@ -2588,7 +2648,7 @@
       </p:sp>
       <p:sp>
         <p:nvSpPr>
-          <p:cNvPr id="5" name="Text 3"/>
+          <p:cNvPr id="6" name="Text 4"/>
           <p:cNvSpPr/>
           <p:nvPr/>
         </p:nvSpPr>
@@ -2739,14 +2799,34 @@
             <a:avLst/>
           </a:prstGeom>
           <a:solidFill>
-            <a:srgbClr val="2E6B4F"/>
+            <a:srgbClr val="1B2A41"/>
           </a:solidFill>
           <a:ln/>
         </p:spPr>
       </p:sp>
       <p:sp>
         <p:nvSpPr>
-          <p:cNvPr id="3" name="Text 1"/>
+          <p:cNvPr id="3" name="Shape 1"/>
+          <p:cNvSpPr/>
+          <p:nvPr/>
+        </p:nvSpPr>
+        <p:spPr>
+          <a:xfrm>
+            <a:off x="0" y="822960"/>
+            <a:ext cx="9144000" cy="45720"/>
+          </a:xfrm>
+          <a:prstGeom prst="rect">
+            <a:avLst/>
+          </a:prstGeom>
+          <a:solidFill>
+            <a:srgbClr val="F4A300"/>
+          </a:solidFill>
+          <a:ln/>
+        </p:spPr>
+      </p:sp>
+      <p:sp>
+        <p:nvSpPr>
+          <p:cNvPr id="4" name="Text 2"/>
           <p:cNvSpPr/>
           <p:nvPr/>
         </p:nvSpPr>
@@ -2785,7 +2865,7 @@
       </p:sp>
       <p:sp>
         <p:nvSpPr>
-          <p:cNvPr id="4" name="Text 2"/>
+          <p:cNvPr id="5" name="Text 3"/>
           <p:cNvSpPr/>
           <p:nvPr/>
         </p:nvSpPr>
@@ -2821,7 +2901,7 @@
       </p:sp>
       <p:sp>
         <p:nvSpPr>
-          <p:cNvPr id="5" name="Text 3"/>
+          <p:cNvPr id="6" name="Text 4"/>
           <p:cNvSpPr/>
           <p:nvPr/>
         </p:nvSpPr>
@@ -2993,14 +3073,34 @@
             <a:avLst/>
           </a:prstGeom>
           <a:solidFill>
-            <a:srgbClr val="2E6B4F"/>
+            <a:srgbClr val="1B2A41"/>
           </a:solidFill>
           <a:ln/>
         </p:spPr>
       </p:sp>
       <p:sp>
         <p:nvSpPr>
-          <p:cNvPr id="3" name="Text 1"/>
+          <p:cNvPr id="3" name="Shape 1"/>
+          <p:cNvSpPr/>
+          <p:nvPr/>
+        </p:nvSpPr>
+        <p:spPr>
+          <a:xfrm>
+            <a:off x="0" y="822960"/>
+            <a:ext cx="9144000" cy="45720"/>
+          </a:xfrm>
+          <a:prstGeom prst="rect">
+            <a:avLst/>
+          </a:prstGeom>
+          <a:solidFill>
+            <a:srgbClr val="F4A300"/>
+          </a:solidFill>
+          <a:ln/>
+        </p:spPr>
+      </p:sp>
+      <p:sp>
+        <p:nvSpPr>
+          <p:cNvPr id="4" name="Text 2"/>
           <p:cNvSpPr/>
           <p:nvPr/>
         </p:nvSpPr>
@@ -3039,7 +3139,7 @@
       </p:sp>
       <p:sp>
         <p:nvSpPr>
-          <p:cNvPr id="4" name="Text 2"/>
+          <p:cNvPr id="5" name="Text 3"/>
           <p:cNvSpPr/>
           <p:nvPr/>
         </p:nvSpPr>
@@ -3075,7 +3175,7 @@
       </p:sp>
       <p:pic>
         <p:nvPicPr>
-          <p:cNvPr id="5" name="Image 0" descr="/home/claude/PanolApp/docs/mockups/login.png">    </p:cNvPr>
+          <p:cNvPr id="6" name="Image 0" descr="/home/claude/PanolApp/docs/mockups/login.png">    </p:cNvPr>
           <p:cNvPicPr>
             <a:picLocks noChangeAspect="1"/>
           </p:cNvPicPr>
@@ -3099,7 +3199,7 @@
       </p:pic>
       <p:pic>
         <p:nvPicPr>
-          <p:cNvPr id="6" name="Image 1" descr="/home/claude/PanolApp/docs/mockups/registro.png">    </p:cNvPr>
+          <p:cNvPr id="7" name="Image 1" descr="/home/claude/PanolApp/docs/mockups/registro.png">    </p:cNvPr>
           <p:cNvPicPr>
             <a:picLocks noChangeAspect="1"/>
           </p:cNvPicPr>
@@ -3123,7 +3223,7 @@
       </p:pic>
       <p:pic>
         <p:nvPicPr>
-          <p:cNvPr id="7" name="Image 2" descr="/home/claude/PanolApp/docs/mockups/menu_admin.png">    </p:cNvPr>
+          <p:cNvPr id="8" name="Image 2" descr="/home/claude/PanolApp/docs/mockups/menu_admin.png">    </p:cNvPr>
           <p:cNvPicPr>
             <a:picLocks noChangeAspect="1"/>
           </p:cNvPicPr>
@@ -3147,7 +3247,7 @@
       </p:pic>
       <p:pic>
         <p:nvPicPr>
-          <p:cNvPr id="8" name="Image 3" descr="/home/claude/PanolApp/docs/mockups/menu_usuario.png">    </p:cNvPr>
+          <p:cNvPr id="9" name="Image 3" descr="/home/claude/PanolApp/docs/mockups/menu_usuario.png">    </p:cNvPr>
           <p:cNvPicPr>
             <a:picLocks noChangeAspect="1"/>
           </p:cNvPicPr>
@@ -3216,14 +3316,34 @@
             <a:avLst/>
           </a:prstGeom>
           <a:solidFill>
-            <a:srgbClr val="2E6B4F"/>
+            <a:srgbClr val="1B2A41"/>
           </a:solidFill>
           <a:ln/>
         </p:spPr>
       </p:sp>
       <p:sp>
         <p:nvSpPr>
-          <p:cNvPr id="3" name="Text 1"/>
+          <p:cNvPr id="3" name="Shape 1"/>
+          <p:cNvSpPr/>
+          <p:nvPr/>
+        </p:nvSpPr>
+        <p:spPr>
+          <a:xfrm>
+            <a:off x="0" y="822960"/>
+            <a:ext cx="9144000" cy="45720"/>
+          </a:xfrm>
+          <a:prstGeom prst="rect">
+            <a:avLst/>
+          </a:prstGeom>
+          <a:solidFill>
+            <a:srgbClr val="F4A300"/>
+          </a:solidFill>
+          <a:ln/>
+        </p:spPr>
+      </p:sp>
+      <p:sp>
+        <p:nvSpPr>
+          <p:cNvPr id="4" name="Text 2"/>
           <p:cNvSpPr/>
           <p:nvPr/>
         </p:nvSpPr>
@@ -3262,7 +3382,7 @@
       </p:sp>
       <p:sp>
         <p:nvSpPr>
-          <p:cNvPr id="4" name="Text 2"/>
+          <p:cNvPr id="5" name="Text 3"/>
           <p:cNvSpPr/>
           <p:nvPr/>
         </p:nvSpPr>
@@ -3298,7 +3418,7 @@
       </p:sp>
       <p:pic>
         <p:nvPicPr>
-          <p:cNvPr id="5" name="Image 0" descr="/home/claude/PanolApp/docs/mockups/inventario.png">    </p:cNvPr>
+          <p:cNvPr id="6" name="Image 0" descr="/home/claude/PanolApp/docs/mockups/inventario.png">    </p:cNvPr>
           <p:cNvPicPr>
             <a:picLocks noChangeAspect="1"/>
           </p:cNvPicPr>
@@ -3322,7 +3442,7 @@
       </p:pic>
       <p:pic>
         <p:nvPicPr>
-          <p:cNvPr id="6" name="Image 1" descr="/home/claude/PanolApp/docs/mockups/formulario.png">    </p:cNvPr>
+          <p:cNvPr id="7" name="Image 1" descr="/home/claude/PanolApp/docs/mockups/formulario.png">    </p:cNvPr>
           <p:cNvPicPr>
             <a:picLocks noChangeAspect="1"/>
           </p:cNvPicPr>
@@ -3346,7 +3466,7 @@
       </p:pic>
       <p:pic>
         <p:nvPicPr>
-          <p:cNvPr id="7" name="Image 2" descr="/home/claude/PanolApp/docs/mockups/detalle.png">    </p:cNvPr>
+          <p:cNvPr id="8" name="Image 2" descr="/home/claude/PanolApp/docs/mockups/detalle.png">    </p:cNvPr>
           <p:cNvPicPr>
             <a:picLocks noChangeAspect="1"/>
           </p:cNvPicPr>
@@ -3370,7 +3490,7 @@
       </p:pic>
       <p:pic>
         <p:nvPicPr>
-          <p:cNvPr id="8" name="Image 3" descr="/home/claude/PanolApp/docs/mockups/prestamos.png">    </p:cNvPr>
+          <p:cNvPr id="9" name="Image 3" descr="/home/claude/PanolApp/docs/mockups/prestamos.png">    </p:cNvPr>
           <p:cNvPicPr>
             <a:picLocks noChangeAspect="1"/>
           </p:cNvPicPr>
@@ -3439,14 +3559,34 @@
             <a:avLst/>
           </a:prstGeom>
           <a:solidFill>
-            <a:srgbClr val="2E6B4F"/>
+            <a:srgbClr val="1B2A41"/>
           </a:solidFill>
           <a:ln/>
         </p:spPr>
       </p:sp>
       <p:sp>
         <p:nvSpPr>
-          <p:cNvPr id="3" name="Text 1"/>
+          <p:cNvPr id="3" name="Shape 1"/>
+          <p:cNvSpPr/>
+          <p:nvPr/>
+        </p:nvSpPr>
+        <p:spPr>
+          <a:xfrm>
+            <a:off x="0" y="822960"/>
+            <a:ext cx="9144000" cy="45720"/>
+          </a:xfrm>
+          <a:prstGeom prst="rect">
+            <a:avLst/>
+          </a:prstGeom>
+          <a:solidFill>
+            <a:srgbClr val="F4A300"/>
+          </a:solidFill>
+          <a:ln/>
+        </p:spPr>
+      </p:sp>
+      <p:sp>
+        <p:nvSpPr>
+          <p:cNvPr id="4" name="Text 2"/>
           <p:cNvSpPr/>
           <p:nvPr/>
         </p:nvSpPr>
@@ -3485,7 +3625,7 @@
       </p:sp>
       <p:sp>
         <p:nvSpPr>
-          <p:cNvPr id="4" name="Text 2"/>
+          <p:cNvPr id="5" name="Text 3"/>
           <p:cNvSpPr/>
           <p:nvPr/>
         </p:nvSpPr>
@@ -3521,7 +3661,7 @@
       </p:sp>
       <p:pic>
         <p:nvPicPr>
-          <p:cNvPr id="5" name="Image 0" descr="/home/claude/PanolApp/docs/mockups/usuarios.png">    </p:cNvPr>
+          <p:cNvPr id="6" name="Image 0" descr="/home/claude/PanolApp/docs/mockups/usuarios.png">    </p:cNvPr>
           <p:cNvPicPr>
             <a:picLocks noChangeAspect="1"/>
           </p:cNvPicPr>
@@ -3545,7 +3685,7 @@
       </p:pic>
       <p:pic>
         <p:nvPicPr>
-          <p:cNvPr id="6" name="Image 1" descr="/home/claude/PanolApp/docs/mockups/perfil.png">    </p:cNvPr>
+          <p:cNvPr id="7" name="Image 1" descr="/home/claude/PanolApp/docs/mockups/perfil.png">    </p:cNvPr>
           <p:cNvPicPr>
             <a:picLocks noChangeAspect="1"/>
           </p:cNvPicPr>
@@ -3614,14 +3754,34 @@
             <a:avLst/>
           </a:prstGeom>
           <a:solidFill>
-            <a:srgbClr val="2E6B4F"/>
+            <a:srgbClr val="1B2A41"/>
           </a:solidFill>
           <a:ln/>
         </p:spPr>
       </p:sp>
       <p:sp>
         <p:nvSpPr>
-          <p:cNvPr id="3" name="Text 1"/>
+          <p:cNvPr id="3" name="Shape 1"/>
+          <p:cNvSpPr/>
+          <p:nvPr/>
+        </p:nvSpPr>
+        <p:spPr>
+          <a:xfrm>
+            <a:off x="0" y="822960"/>
+            <a:ext cx="9144000" cy="45720"/>
+          </a:xfrm>
+          <a:prstGeom prst="rect">
+            <a:avLst/>
+          </a:prstGeom>
+          <a:solidFill>
+            <a:srgbClr val="F4A300"/>
+          </a:solidFill>
+          <a:ln/>
+        </p:spPr>
+      </p:sp>
+      <p:sp>
+        <p:nvSpPr>
+          <p:cNvPr id="4" name="Text 2"/>
           <p:cNvSpPr/>
           <p:nvPr/>
         </p:nvSpPr>
@@ -3660,7 +3820,7 @@
       </p:sp>
       <p:sp>
         <p:nvSpPr>
-          <p:cNvPr id="4" name="Text 2"/>
+          <p:cNvPr id="5" name="Text 3"/>
           <p:cNvSpPr/>
           <p:nvPr/>
         </p:nvSpPr>
@@ -3696,7 +3856,7 @@
       </p:sp>
       <p:sp>
         <p:nvSpPr>
-          <p:cNvPr id="5" name="Text 3"/>
+          <p:cNvPr id="6" name="Text 4"/>
           <p:cNvSpPr/>
           <p:nvPr/>
         </p:nvSpPr>
@@ -3868,14 +4028,34 @@
             <a:avLst/>
           </a:prstGeom>
           <a:solidFill>
-            <a:srgbClr val="2E6B4F"/>
+            <a:srgbClr val="1B2A41"/>
           </a:solidFill>
           <a:ln/>
         </p:spPr>
       </p:sp>
       <p:sp>
         <p:nvSpPr>
-          <p:cNvPr id="3" name="Text 1"/>
+          <p:cNvPr id="3" name="Shape 1"/>
+          <p:cNvSpPr/>
+          <p:nvPr/>
+        </p:nvSpPr>
+        <p:spPr>
+          <a:xfrm>
+            <a:off x="0" y="822960"/>
+            <a:ext cx="9144000" cy="45720"/>
+          </a:xfrm>
+          <a:prstGeom prst="rect">
+            <a:avLst/>
+          </a:prstGeom>
+          <a:solidFill>
+            <a:srgbClr val="F4A300"/>
+          </a:solidFill>
+          <a:ln/>
+        </p:spPr>
+      </p:sp>
+      <p:sp>
+        <p:nvSpPr>
+          <p:cNvPr id="4" name="Text 2"/>
           <p:cNvSpPr/>
           <p:nvPr/>
         </p:nvSpPr>
@@ -3914,7 +4094,7 @@
       </p:sp>
       <p:sp>
         <p:nvSpPr>
-          <p:cNvPr id="4" name="Text 2"/>
+          <p:cNvPr id="5" name="Text 3"/>
           <p:cNvSpPr/>
           <p:nvPr/>
         </p:nvSpPr>
@@ -3950,7 +4130,7 @@
       </p:sp>
       <p:sp>
         <p:nvSpPr>
-          <p:cNvPr id="5" name="Text 3"/>
+          <p:cNvPr id="6" name="Text 4"/>
           <p:cNvSpPr/>
           <p:nvPr/>
         </p:nvSpPr>
@@ -4143,14 +4323,34 @@
             <a:avLst/>
           </a:prstGeom>
           <a:solidFill>
-            <a:srgbClr val="2E6B4F"/>
+            <a:srgbClr val="1B2A41"/>
           </a:solidFill>
           <a:ln/>
         </p:spPr>
       </p:sp>
       <p:sp>
         <p:nvSpPr>
-          <p:cNvPr id="3" name="Text 1"/>
+          <p:cNvPr id="3" name="Shape 1"/>
+          <p:cNvSpPr/>
+          <p:nvPr/>
+        </p:nvSpPr>
+        <p:spPr>
+          <a:xfrm>
+            <a:off x="0" y="822960"/>
+            <a:ext cx="9144000" cy="45720"/>
+          </a:xfrm>
+          <a:prstGeom prst="rect">
+            <a:avLst/>
+          </a:prstGeom>
+          <a:solidFill>
+            <a:srgbClr val="F4A300"/>
+          </a:solidFill>
+          <a:ln/>
+        </p:spPr>
+      </p:sp>
+      <p:sp>
+        <p:nvSpPr>
+          <p:cNvPr id="4" name="Text 2"/>
           <p:cNvSpPr/>
           <p:nvPr/>
         </p:nvSpPr>
@@ -4189,7 +4389,7 @@
       </p:sp>
       <p:sp>
         <p:nvSpPr>
-          <p:cNvPr id="4" name="Text 2"/>
+          <p:cNvPr id="5" name="Text 3"/>
           <p:cNvSpPr/>
           <p:nvPr/>
         </p:nvSpPr>
@@ -4225,7 +4425,7 @@
       </p:sp>
       <p:sp>
         <p:nvSpPr>
-          <p:cNvPr id="5" name="Text 3"/>
+          <p:cNvPr id="6" name="Text 4"/>
           <p:cNvSpPr/>
           <p:nvPr/>
         </p:nvSpPr>

</xml_diff>